<commit_message>
Fix S2 property names (name not nome/employee_name), add thorough comments
</commit_message>
<xml_diff>
--- a/slides/session-02/session-02.pptx
+++ b/slides/session-02/session-02.pptx
@@ -24538,7 +24538,7 @@
               </a:defRPr>
             </a:pPr>
             <a:r>
-              <a:t>RETURN {nome: "Alice", eta: 30}.nome AS nome;</a:t>
+              <a:t>RETURN {nome: "Alice", eta: 30}.name AS nome;</a:t>
             </a:r>
           </a:p>
         </p:txBody>
@@ -24819,7 +24819,7 @@
               </a:defRPr>
             </a:pPr>
             <a:r>
-              <a:t>RETURN p.nome, s.nome;</a:t>
+              <a:t>RETURN p.name, s.name;</a:t>
             </a:r>
           </a:p>
           <a:p>
@@ -24896,7 +24896,7 @@
               </a:defRPr>
             </a:pPr>
             <a:r>
-              <a:t>RETURN p.nome, s.nome;</a:t>
+              <a:t>RETURN p.name, s.name;</a:t>
             </a:r>
           </a:p>
           <a:p>
@@ -25360,7 +25360,7 @@
               </a:defRPr>
             </a:pPr>
             <a:r>
-              <a:t>  SET p.nome = row.nome;</a:t>
+              <a:t>  SET p.name = row.name;</a:t>
             </a:r>
           </a:p>
           <a:p>
@@ -27063,7 +27063,7 @@
               </a:defRPr>
             </a:pPr>
             <a:r>
-              <a:t>RETURN p1.nome, p2.nome, proj.nome</a:t>
+              <a:t>RETURN p1.name, p2.name, proj.name</a:t>
             </a:r>
           </a:p>
           <a:p>
@@ -27124,7 +27124,7 @@
               </a:defRPr>
             </a:pPr>
             <a:r>
-              <a:t>RETURN p.nome AS impiegato, m.nome AS manager</a:t>
+              <a:t>RETURN p.name AS impiegato, m.name AS manager</a:t>
             </a:r>
           </a:p>
           <a:p>
@@ -27495,7 +27495,7 @@
               </a:defRPr>
             </a:pPr>
             <a:r>
-              <a:t>  SET p.nome = "Alice";</a:t>
+              <a:t>  SET p.name = "Alice";</a:t>
             </a:r>
           </a:p>
           <a:p>
@@ -27572,7 +27572,7 @@
               </a:defRPr>
             </a:pPr>
             <a:r>
-              <a:t>  SET h.livello = "Senior";</a:t>
+              <a:t>  SET h.proficiency = "Senior";</a:t>
             </a:r>
           </a:p>
           <a:p>
@@ -27914,7 +27914,7 @@
               </a:defRPr>
             </a:pPr>
             <a:r>
-              <a:t>RETURN p.nome, p.location, p.eta;</a:t>
+              <a:t>RETURN p.name, p.location, p.eta;</a:t>
             </a:r>
           </a:p>
           <a:p>
@@ -27975,7 +27975,7 @@
               </a:defRPr>
             </a:pPr>
             <a:r>
-              <a:t>WHERE s.nome CONTAINS "cloud"</a:t>
+              <a:t>WHERE s.name CONTAINS "cloud"</a:t>
             </a:r>
           </a:p>
           <a:p>
@@ -27991,7 +27991,7 @@
               </a:defRPr>
             </a:pPr>
             <a:r>
-              <a:t>RETURN s.nome;</a:t>
+              <a:t>RETURN s.name;</a:t>
             </a:r>
           </a:p>
           <a:p>
@@ -28068,7 +28068,7 @@
               </a:defRPr>
             </a:pPr>
             <a:r>
-              <a:t>RETURN p.nome, p.location;</a:t>
+              <a:t>RETURN p.name, p.location;</a:t>
             </a:r>
           </a:p>
         </p:txBody>
@@ -28333,7 +28333,7 @@
               </a:defRPr>
             </a:pPr>
             <a:r>
-              <a:t>RETURN s.nome, count(*) AS persone</a:t>
+              <a:t>RETURN s.name, count(*) AS persone</a:t>
             </a:r>
           </a:p>
           <a:p>
@@ -28410,7 +28410,7 @@
               </a:defRPr>
             </a:pPr>
             <a:r>
-              <a:t>RETURN s.nome, avg(h.livello) AS media</a:t>
+              <a:t>RETURN s.name, avg(h.proficiency) AS media</a:t>
             </a:r>
           </a:p>
           <a:p>
@@ -28487,7 +28487,7 @@
               </a:defRPr>
             </a:pPr>
             <a:r>
-              <a:t>RETURN p.nome, collect(proj.nome) AS progetti;</a:t>
+              <a:t>RETURN p.name, collect(proj.name) AS progetti;</a:t>
             </a:r>
           </a:p>
         </p:txBody>
@@ -28752,7 +28752,7 @@
               </a:defRPr>
             </a:pPr>
             <a:r>
-              <a:t>RETURN s.nome, count(*) AS cnt</a:t>
+              <a:t>RETURN s.name, count(*) AS cnt</a:t>
             </a:r>
           </a:p>
           <a:p>
@@ -28829,7 +28829,7 @@
               </a:defRPr>
             </a:pPr>
             <a:r>
-              <a:t>RETURN p.nome, collect(s.nome) AS skills</a:t>
+              <a:t>RETURN p.name, collect(s.name) AS skills</a:t>
             </a:r>
           </a:p>
           <a:p>
@@ -28845,7 +28845,7 @@
               </a:defRPr>
             </a:pPr>
             <a:r>
-              <a:t>ORDER BY p.nome</a:t>
+              <a:t>ORDER BY p.name</a:t>
             </a:r>
           </a:p>
           <a:p>
@@ -29110,7 +29110,7 @@
               </a:defRPr>
             </a:pPr>
             <a:r>
-              <a:t>CALL { MATCH (s:Skill) RETURN s.nome AS nome, "Skill" AS tipo }</a:t>
+              <a:t>CALL { MATCH (s:Skill) RETURN s.name AS nome, "Skill" AS tipo }</a:t>
             </a:r>
           </a:p>
           <a:p>
@@ -29142,7 +29142,7 @@
               </a:defRPr>
             </a:pPr>
             <a:r>
-              <a:t>CALL { MATCH (p:Project) RETURN p.nome AS nome, "Progetto" AS tipo }</a:t>
+              <a:t>CALL { MATCH (p:Project) RETURN p.name AS nome, "Progetto" AS tipo }</a:t>
             </a:r>
           </a:p>
           <a:p>
@@ -29219,7 +29219,7 @@
               </a:defRPr>
             </a:pPr>
             <a:r>
-              <a:t>RETURN p.nome,</a:t>
+              <a:t>RETURN p.name,</a:t>
             </a:r>
           </a:p>
           <a:p>

</xml_diff>

<commit_message>
Fix queries: REPORTS_TO goes to Supervisor not Person, add exploration step
</commit_message>
<xml_diff>
--- a/slides/session-02/session-02.pptx
+++ b/slides/session-02/session-02.pptx
@@ -27092,7 +27092,7 @@
               </a:defRPr>
             </a:pPr>
             <a:r>
-              <a:t>// Path a lunghezza variabile (catena di comando):</a:t>
+              <a:t>// Person -&gt; Supervisor (riporto diretto):</a:t>
             </a:r>
           </a:p>
           <a:p>
@@ -27108,7 +27108,7 @@
               </a:defRPr>
             </a:pPr>
             <a:r>
-              <a:t>MATCH (p:Person)-[:REPORTS_TO*1..4]-&gt;(m:Person)</a:t>
+              <a:t>MATCH (p:Person)-[:REPORTS_TO]-&gt;(s:Supervisor)</a:t>
             </a:r>
           </a:p>
           <a:p>
@@ -27124,7 +27124,7 @@
               </a:defRPr>
             </a:pPr>
             <a:r>
-              <a:t>RETURN p.name AS impiegato, m.name AS manager</a:t>
+              <a:t>RETURN p.name AS impiegato, s.name AS supervisor</a:t>
             </a:r>
           </a:p>
           <a:p>

</xml_diff>